<commit_message>
Semana 4: impacto social y responsabilidad (workshop, model card, datasheet, auditoría de equidad por jurisdicción, pt en revisión obligatoria, diapositiva 16)
Co-Authored-By: Claude Fable 5.1 <noreply@anthropic.com>
Claude-Session: https://claude.ai/code/session_01WoNHoUaGaerBW2JnaGJH3V
</commit_message>
<xml_diff>
--- a/docs/presentacion_final/Grupo_9_Presentacion_Final.pptx
+++ b/docs/presentacion_final/Grupo_9_Presentacion_Final.pptx
@@ -23,9 +23,10 @@
     <p:sldId id="271" r:id="rId17"/>
     <p:sldId id="272" r:id="rId18"/>
     <p:sldId id="273" r:id="rId19"/>
+    <p:sldId id="274" r:id="rId20"/>
   </p:sldIdLst>
   <p:notesMasterIdLst>
-    <p:notesMasterId r:id="rId20"/>
+    <p:notesMasterId r:id="rId21"/>
   </p:notesMasterIdLst>
   <p:sldSz cx="12192000" cy="6858000"/>
   <p:notesSz cx="6858000" cy="12192000"/>
@@ -1591,9 +1592,9 @@
           <a:p>
             <a:r>
               <a:rPr lang="en-US" dirty="0"/>
-              <a:t>[12:25–13:25] Operación: codificación asistida, no automatización
-¿Puede el observatorio automatizar parte de la codificación? La curva de enrutamiento responde: para garantizar al menos 85 por ciento de exactitud en el tramo automático, el umbral de confianza debe ser 0.50, y con la regla completa —umbral, países con menos de 20 normas e idiomas minoritarios— el 84 por ciento de las normas va a revisión humana. La meta era 30 por ciento; el ahorro sería de 22 horas sobre 136 por pasada.
-La conclusión operativa es codificación asistida, no automática: el modelo propone dos candidatas con su probabilidad, el codificador decide, y la tabla del índice registra por país cuántas normas tienen respaldo humano y cuántas solo del modelo, con un margen. El índice no queda a merced del modelo; el modelo reduce el espacio de decisión de cinco opciones a dos en el 85 por ciento de los casos.</a:t>
+              <a:t>[12:25–13:10] Operación: codificación asistida, no automatización
+¿Puede el observatorio automatizar parte de la codificación? La curva de enrutamiento responde: para garantizar al menos 85 por ciento de exactitud en el tramo automático, el umbral de confianza debe ser 0.50, y con la regla completa el 84 por ciento de las normas va a revisión humana; la meta era 30 por ciento y el ahorro sería de 21 horas sobre 136 por pasada.
+La conclusión operativa es codificación asistida, no automática: el modelo propone dos candidatas con su probabilidad, el codificador decide, y la tabla del índice registra por país cuántas normas tienen respaldo humano y cuántas solo del modelo. El modelo reduce el espacio de decisión de cinco opciones a dos en el 85 por ciento de los casos.</a:t>
             </a:r>
             <a:endParaRPr lang="en-US" dirty="0"/>
           </a:p>
@@ -1681,9 +1682,8 @@
           <a:p>
             <a:r>
               <a:rPr lang="en-US" dirty="0"/>
-              <a:t>[13:25–14:10] Contraste con los umbrales prefijados y limitaciones
-Contrastamos cada resultado con el criterio prefijado. Superar ambas líneas base con significancia: cumplido. F1 macro mínimo de 0.60: en el borde, 0.587 en validación cruzada y 0.617 en el conjunto ciego. Excelencia de 0.70: no alcanzado. Ninguna clase bajo 0.40: incumplido por Técnico. Kappa de 0.60: no alcanzado, con 0.50 y 0.56. Enrutar menos del 30 por ciento con 85 por ciento de exactitud: no viable.
-Las limitaciones: un solo codificador por norma en la referencia, así que parte del error puede ser desacuerdo legítimo; el kappa humano-humano sigue pendiente y la plantilla para obtenerlo está generada. Texto corto y en parte redactado por el codificador. Conjunto ciego pequeño. Y la rama LLM pendiente de ejecución.</a:t>
+              <a:t>[13:10–13:55] Impacto social y responsabilidad
+El impacto social del sistema está en el índice que compara países. Auditamos la equidad por jurisdicción: el modelo acierta 0.67 en Hispanoamérica continental, 0.47 en Brasil y 0.38 en el Caribe. Automatizado sin salvaguardas, el índice invisibilizaría justo a las jurisdicciones que un observatorio regional debería hacer visibles. La regla de gobernanza envía a revisión humana el cien por ciento de esas normas, y la auditoría nos obligó a corregirla: Brasil quedaba fuera y lo incorporamos. El nombre del codificador es un dato personal que se excluye y anonimiza; bajo la Ley de IA europea el sistema es de riesgo mínimo, pero adoptamos voluntariamente model card, datasheet y plan de incidentes. Compromiso: ninguna cifra del índice sin revisión humana en los grupos en riesgo, siempre con su margen, y nunca para evaluar a codificadores.</a:t>
             </a:r>
             <a:endParaRPr lang="en-US" dirty="0"/>
           </a:p>
@@ -1771,9 +1771,9 @@
           <a:p>
             <a:r>
               <a:rPr lang="en-US" dirty="0"/>
-              <a:t>[14:10–14:50] Conclusiones y trabajo futuro
-Tres conclusiones. Primera: con 813 normas y texto corto, un modelo lineal interpretable aprende la estructura del framework GENIAL y supera con significancia a cualquier heurística sin IA, pero no alcanza la calidad necesaria para sustituir al codificador. Segunda: el valor del clasificador está en la asistencia —dos candidatas correctas en el 85 por ciento de los casos— y en el diagnóstico: sus errores señalan normas de frontera y dimensiones cuya definición conviene revisar. Tercera: los umbrales prefijados, los intervalos de confianza y las pruebas pareadas son lo que permite decir esto con rigor en lugar de celebrar una cifra.
-Como trabajo futuro: cerrar la comparación con la rama LLM few-shot; incorporar la doble codificación para medir el techo humano; ampliar el texto de entrada con el cuerpo de la norma; y evaluar un esquema explícitamente multi-etiqueta cuando la tipificación de errores lo justifique.</a:t>
+              <a:t>[13:55–14:25] Contraste con los umbrales prefijados y limitaciones
+Contrastamos cada resultado con el criterio prefijado. Superar ambas líneas base con significancia: cumplido. F1 macro mínimo de 0.60: en el borde, 0.587 en validación cruzada y 0.617 en el conjunto ciego. Excelencia de 0.70: no alcanzado. Ninguna clase bajo 0.40: incumplido por Técnico. Kappa de 0.60: no alcanzado, con 0.50 y 0.56. Enrutar menos del 30 por ciento con 85 por ciento de exactitud: no viable.
+Las limitaciones: un solo codificador por norma en la referencia, así que parte del error puede ser desacuerdo legítimo; el kappa humano-humano sigue pendiente y la plantilla para obtenerlo está generada. Texto corto y en parte redactado por el codificador. Conjunto ciego pequeño. Y la rama LLM pendiente de ejecución.</a:t>
             </a:r>
             <a:endParaRPr lang="en-US" dirty="0"/>
           </a:p>
@@ -1861,8 +1861,9 @@
           <a:p>
             <a:r>
               <a:rPr lang="en-US" dirty="0"/>
-              <a:t>[14:50–15:00] Cierre
-Todo el código, el cuaderno ejecutado, las figuras, la síntesis de resultados y la documentación están en el repositorio público github.com/jorgemaldonadom-cmd/genial-clasificador-normativa, con licencia MIT para el código y una muestra anonimizada del corpus. Agradecemos al proyecto GENIAL por el acceso al corpus y a la profesora Gladys Villegas por su acompañamiento. Muchas gracias.</a:t>
+              <a:t>[14:25–14:50] Conclusiones y trabajo futuro
+Tres conclusiones. Primera: con 813 normas y texto corto, un modelo lineal interpretable aprende la estructura del framework GENIAL y supera con significancia a toda heurística sin IA, pero no alcanza la calidad para sustituir al codificador. Segunda: su valor está en la asistencia —dos candidatas correctas en el 85 por ciento de los casos— y en el diagnóstico: sus errores señalan normas de frontera y dimensiones cuya definición conviene revisar. Tercera: umbrales prefijados, intervalos de confianza y pruebas pareadas permiten decirlo con rigor.
+Trabajo futuro: cerrar la comparación con la rama LLM, medir el techo humano con doble codificación, ampliar el texto de entrada y evaluar un esquema multi-etiqueta.</a:t>
             </a:r>
             <a:endParaRPr lang="en-US" dirty="0"/>
           </a:p>
@@ -1886,6 +1887,95 @@
             <a:fld id="{F7021451-1387-4CA6-816F-3879F97B5CBC}" type="slidenum">
               <a:rPr lang="en-US"/>
               <a:t>18</a:t>
+            </a:fld>
+            <a:endParaRPr lang="en-US"/>
+          </a:p>
+        </p:txBody>
+      </p:sp>
+    </p:spTree>
+    <p:extLst>
+      <p:ext uri="{BB962C8B-B14F-4D97-AF65-F5344CB8AC3E}">
+        <p14:creationId xmlns:p14="http://schemas.microsoft.com/office/powerpoint/2010/main" val="1024086991"/>
+      </p:ext>
+    </p:extLst>
+  </p:cSld>
+  <p:clrMapOvr>
+    <a:masterClrMapping/>
+  </p:clrMapOvr>
+</p:notes>
+</file>
+
+<file path=ppt/notesSlides/notesSlide19.xml><?xml version="1.0" encoding="utf-8"?>
+<p:notes xmlns:a="http://schemas.openxmlformats.org/drawingml/2006/main" xmlns:r="http://schemas.openxmlformats.org/officeDocument/2006/relationships" xmlns:p="http://schemas.openxmlformats.org/presentationml/2006/main">
+  <p:cSld>
+    <p:spTree>
+      <p:nvGrpSpPr>
+        <p:cNvPr id="1" name=""/>
+        <p:cNvGrpSpPr/>
+        <p:nvPr/>
+      </p:nvGrpSpPr>
+      <p:grpSpPr>
+        <a:xfrm>
+          <a:off x="0" y="0"/>
+          <a:ext cx="0" cy="0"/>
+          <a:chOff x="0" y="0"/>
+          <a:chExt cx="0" cy="0"/>
+        </a:xfrm>
+      </p:grpSpPr>
+      <p:sp>
+        <p:nvSpPr>
+          <p:cNvPr id="2" name="Slide Image Placeholder 1"/>
+          <p:cNvSpPr>
+            <a:spLocks noGrp="1" noRot="1" noChangeAspect="1"/>
+          </p:cNvSpPr>
+          <p:nvPr>
+            <p:ph type="sldImg"/>
+          </p:nvPr>
+        </p:nvSpPr>
+        <p:spPr/>
+      </p:sp>
+      <p:sp>
+        <p:nvSpPr>
+          <p:cNvPr id="3" name="Notes Placeholder 2"/>
+          <p:cNvSpPr>
+            <a:spLocks noGrp="1"/>
+          </p:cNvSpPr>
+          <p:nvPr>
+            <p:ph type="body" idx="1"/>
+          </p:nvPr>
+        </p:nvSpPr>
+        <p:spPr/>
+        <p:txBody>
+          <a:bodyPr/>
+          <a:lstStyle/>
+          <a:p>
+            <a:r>
+              <a:rPr lang="en-US" dirty="0"/>
+              <a:t>[14:50–15:00] Cierre
+Todo el código, el cuaderno ejecutado, las figuras, la síntesis de resultados y la documentación están en el repositorio público github.com/jorgemaldonadom-cmd/genial-clasificador-normativa, con licencia MIT para el código y una muestra anonimizada del corpus. Agradecemos al proyecto GENIAL por el acceso al corpus y a la profesora Gladys Villegas por su acompañamiento. Muchas gracias.</a:t>
+            </a:r>
+            <a:endParaRPr lang="en-US" dirty="0"/>
+          </a:p>
+        </p:txBody>
+      </p:sp>
+      <p:sp>
+        <p:nvSpPr>
+          <p:cNvPr id="4" name="Slide Number Placeholder 3"/>
+          <p:cNvSpPr>
+            <a:spLocks noGrp="1"/>
+          </p:cNvSpPr>
+          <p:nvPr>
+            <p:ph type="sldNum" sz="quarter" idx="10"/>
+          </p:nvPr>
+        </p:nvSpPr>
+        <p:spPr/>
+        <p:txBody>
+          <a:bodyPr/>
+          <a:lstStyle/>
+          <a:p>
+            <a:fld id="{F7021451-1387-4CA6-816F-3879F97B5CBC}" type="slidenum">
+              <a:rPr lang="en-US"/>
+              <a:t>19</a:t>
             </a:fld>
             <a:endParaRPr lang="en-US"/>
           </a:p>
@@ -14257,7 +14347,7 @@
                 <a:ea typeface="Cambria" pitchFamily="34" charset="-122"/>
                 <a:cs typeface="Cambria" pitchFamily="34" charset="-120"/>
               </a:rPr>
-              <a:t>22 / 136</a:t>
+              <a:t>21 / 136</a:t>
             </a:r>
             <a:endParaRPr lang="en-US" sz="4000" dirty="0"/>
           </a:p>
@@ -14617,6 +14707,714 @@
                 <a:ea typeface="Cambria" pitchFamily="34" charset="-122"/>
                 <a:cs typeface="Cambria" pitchFamily="34" charset="-120"/>
               </a:rPr>
+              <a:t>Impacto social y responsabilidad: escalar sin invisibilizar</a:t>
+            </a:r>
+            <a:endParaRPr lang="en-US" sz="2800" dirty="0"/>
+          </a:p>
+        </p:txBody>
+      </p:sp>
+      <p:sp>
+        <p:nvSpPr>
+          <p:cNvPr id="5" name="Text 3"/>
+          <p:cNvSpPr txBox="1"/>
+          <p:nvPr/>
+        </p:nvSpPr>
+        <p:spPr>
+          <a:xfrm>
+            <a:off x="1188720" y="960120"/>
+            <a:ext cx="10454335" cy="365760"/>
+          </a:xfrm>
+          <a:prstGeom prst="rect">
+            <a:avLst/>
+          </a:prstGeom>
+          <a:noFill/>
+          <a:ln/>
+        </p:spPr>
+        <p:txBody>
+          <a:bodyPr wrap="square" lIns="0" tIns="0" rIns="0" bIns="0" rtlCol="0" anchor="ctr"/>
+          <a:lstStyle/>
+          <a:p>
+            <a:pPr indent="0" marL="0">
+              <a:buNone/>
+            </a:pPr>
+            <a:r>
+              <a:rPr lang="en-US" sz="1400" i="1" dirty="0">
+                <a:solidFill>
+                  <a:srgbClr val="6E6862"/>
+                </a:solidFill>
+                <a:latin typeface="Calibri" pitchFamily="34" charset="0"/>
+                <a:ea typeface="Calibri" pitchFamily="34" charset="-122"/>
+                <a:cs typeface="Calibri" pitchFamily="34" charset="-120"/>
+              </a:rPr>
+              <a:t>Auditoría de equidad por jurisdicción (CV por grupo, n = 813) · regla de gobernanza · cadena de responsabilidad</a:t>
+            </a:r>
+            <a:endParaRPr lang="en-US" sz="1400" dirty="0"/>
+          </a:p>
+        </p:txBody>
+      </p:sp>
+      <p:sp>
+        <p:nvSpPr>
+          <p:cNvPr id="6" name="Text 4"/>
+          <p:cNvSpPr txBox="1"/>
+          <p:nvPr/>
+        </p:nvSpPr>
+        <p:spPr>
+          <a:xfrm>
+            <a:off x="548640" y="6400800"/>
+            <a:ext cx="6400800" cy="274320"/>
+          </a:xfrm>
+          <a:prstGeom prst="rect">
+            <a:avLst/>
+          </a:prstGeom>
+          <a:noFill/>
+          <a:ln/>
+        </p:spPr>
+        <p:txBody>
+          <a:bodyPr wrap="square" lIns="0" tIns="0" rIns="0" bIns="0" rtlCol="0" anchor="ctr"/>
+          <a:lstStyle/>
+          <a:p>
+            <a:pPr indent="0" marL="0">
+              <a:buNone/>
+            </a:pPr>
+            <a:r>
+              <a:rPr lang="en-US" sz="900" dirty="0">
+                <a:solidFill>
+                  <a:srgbClr val="6E6862"/>
+                </a:solidFill>
+                <a:latin typeface="Calibri" pitchFamily="34" charset="0"/>
+                <a:ea typeface="Calibri" pitchFamily="34" charset="-122"/>
+                <a:cs typeface="Calibri" pitchFamily="34" charset="-120"/>
+              </a:rPr>
+              <a:t>Grupo 9 · Proyecto Integrador en IA · UEES · 2026</a:t>
+            </a:r>
+            <a:endParaRPr lang="en-US" sz="900" dirty="0"/>
+          </a:p>
+        </p:txBody>
+      </p:sp>
+      <p:sp>
+        <p:nvSpPr>
+          <p:cNvPr id="7" name="Text 5"/>
+          <p:cNvSpPr txBox="1"/>
+          <p:nvPr/>
+        </p:nvSpPr>
+        <p:spPr>
+          <a:xfrm>
+            <a:off x="10728655" y="6400800"/>
+            <a:ext cx="914400" cy="274320"/>
+          </a:xfrm>
+          <a:prstGeom prst="rect">
+            <a:avLst/>
+          </a:prstGeom>
+          <a:noFill/>
+          <a:ln/>
+        </p:spPr>
+        <p:txBody>
+          <a:bodyPr wrap="square" lIns="0" tIns="0" rIns="0" bIns="0" rtlCol="0" anchor="ctr"/>
+          <a:lstStyle/>
+          <a:p>
+            <a:pPr algn="r" indent="0" marL="0">
+              <a:buNone/>
+            </a:pPr>
+            <a:r>
+              <a:rPr lang="en-US" sz="900" dirty="0">
+                <a:solidFill>
+                  <a:srgbClr val="6E6862"/>
+                </a:solidFill>
+                <a:latin typeface="Calibri" pitchFamily="34" charset="0"/>
+                <a:ea typeface="Calibri" pitchFamily="34" charset="-122"/>
+                <a:cs typeface="Calibri" pitchFamily="34" charset="-120"/>
+              </a:rPr>
+              <a:t>16</a:t>
+            </a:r>
+            <a:endParaRPr lang="en-US" sz="900" dirty="0"/>
+          </a:p>
+        </p:txBody>
+      </p:sp>
+      <p:pic>
+        <p:nvPicPr>
+          <p:cNvPr id="9" name="Image 0" descr="12_fairness_grupos.png">    </p:cNvPr>
+          <p:cNvPicPr>
+            <a:picLocks noChangeAspect="1"/>
+          </p:cNvPicPr>
+          <p:nvPr/>
+        </p:nvPicPr>
+        <p:blipFill>
+          <a:blip r:embed="rId1"/>
+          <a:stretch>
+            <a:fillRect/>
+          </a:stretch>
+        </p:blipFill>
+        <p:spPr>
+          <a:xfrm>
+            <a:off x="548640" y="1417320"/>
+            <a:ext cx="6949440" cy="2663952"/>
+          </a:xfrm>
+          <a:prstGeom prst="rect">
+            <a:avLst/>
+          </a:prstGeom>
+        </p:spPr>
+      </p:pic>
+      <p:sp>
+        <p:nvSpPr>
+          <p:cNvPr id="10" name="Shape 6"/>
+          <p:cNvSpPr/>
+          <p:nvPr/>
+        </p:nvSpPr>
+        <p:spPr>
+          <a:xfrm>
+            <a:off x="548640" y="4206240"/>
+            <a:ext cx="6949440" cy="1737360"/>
+          </a:xfrm>
+          <a:prstGeom prst="roundRect">
+            <a:avLst>
+              <a:gd name="adj" fmla="val 4211"/>
+            </a:avLst>
+          </a:prstGeom>
+          <a:solidFill>
+            <a:srgbClr val="F4F2EF"/>
+          </a:solidFill>
+          <a:ln w="12700">
+            <a:solidFill>
+              <a:srgbClr val="F4F2EF"/>
+            </a:solidFill>
+            <a:prstDash val="solid"/>
+          </a:ln>
+        </p:spPr>
+      </p:sp>
+      <p:sp>
+        <p:nvSpPr>
+          <p:cNvPr id="11" name="Text 7"/>
+          <p:cNvSpPr txBox="1"/>
+          <p:nvPr/>
+        </p:nvSpPr>
+        <p:spPr>
+          <a:xfrm>
+            <a:off x="731520" y="4343400"/>
+            <a:ext cx="6583680" cy="365760"/>
+          </a:xfrm>
+          <a:prstGeom prst="rect">
+            <a:avLst/>
+          </a:prstGeom>
+          <a:noFill/>
+          <a:ln/>
+        </p:spPr>
+        <p:txBody>
+          <a:bodyPr wrap="square" lIns="0" tIns="0" rIns="0" bIns="0" rtlCol="0" anchor="t"/>
+          <a:lstStyle/>
+          <a:p>
+            <a:pPr indent="0" marL="0">
+              <a:buNone/>
+            </a:pPr>
+            <a:r>
+              <a:rPr lang="en-US" sz="1400" b="1" dirty="0">
+                <a:solidFill>
+                  <a:srgbClr val="7A1F3D"/>
+                </a:solidFill>
+                <a:latin typeface="Calibri" pitchFamily="34" charset="0"/>
+                <a:ea typeface="Calibri" pitchFamily="34" charset="-122"/>
+                <a:cs typeface="Calibri" pitchFamily="34" charset="-120"/>
+              </a:rPr>
+              <a:t>Lo que muestra la auditoría</a:t>
+            </a:r>
+            <a:endParaRPr lang="en-US" sz="1400" dirty="0"/>
+          </a:p>
+        </p:txBody>
+      </p:sp>
+      <p:sp>
+        <p:nvSpPr>
+          <p:cNvPr id="12" name="Text 8"/>
+          <p:cNvSpPr txBox="1"/>
+          <p:nvPr/>
+        </p:nvSpPr>
+        <p:spPr>
+          <a:xfrm>
+            <a:off x="731520" y="4709160"/>
+            <a:ext cx="6583680" cy="1097280"/>
+          </a:xfrm>
+          <a:prstGeom prst="rect">
+            <a:avLst/>
+          </a:prstGeom>
+          <a:noFill/>
+          <a:ln/>
+        </p:spPr>
+        <p:txBody>
+          <a:bodyPr wrap="square" lIns="0" tIns="0" rIns="0" bIns="0" rtlCol="0" anchor="t"/>
+          <a:lstStyle/>
+          <a:p>
+            <a:pPr marL="342900" indent="-342900">
+              <a:spcAft>
+                <a:spcPts val="400"/>
+              </a:spcAft>
+              <a:buSzPct val="100000"/>
+              <a:buChar char="•"/>
+            </a:pPr>
+            <a:r>
+              <a:rPr lang="en-US" sz="1100" dirty="0">
+                <a:solidFill>
+                  <a:srgbClr val="1B1A19"/>
+                </a:solidFill>
+                <a:latin typeface="Calibri" pitchFamily="34" charset="0"/>
+                <a:ea typeface="Calibri" pitchFamily="34" charset="-122"/>
+                <a:cs typeface="Calibri" pitchFamily="34" charset="-120"/>
+              </a:rPr>
+              <a:t>El modelo rinde peor donde hay menos datos: Caribe 0.38 y Brasil 0.47 frente a 0.67 en Hispanoamérica continental; inglés 0.36 frente a español 0.66 (razón &lt; 0.8).</a:t>
+            </a:r>
+            <a:endParaRPr lang="en-US" sz="1100" dirty="0"/>
+          </a:p>
+          <a:p>
+            <a:pPr marL="342900" indent="-342900">
+              <a:spcAft>
+                <a:spcPts val="400"/>
+              </a:spcAft>
+              <a:buSzPct val="100000"/>
+              <a:buChar char="•"/>
+            </a:pPr>
+            <a:r>
+              <a:rPr lang="en-US" sz="1100" dirty="0">
+                <a:solidFill>
+                  <a:srgbClr val="1B1A19"/>
+                </a:solidFill>
+                <a:latin typeface="Calibri" pitchFamily="34" charset="0"/>
+                <a:ea typeface="Calibri" pitchFamily="34" charset="-122"/>
+                <a:cs typeface="Calibri" pitchFamily="34" charset="-120"/>
+              </a:rPr>
+              <a:t>La regla de gobernanza envía a revisión humana el 100 % de esas normas; tras la auditoría se añadió el portugués (Brasil pasaba al tramo automático con exactitud 0.33).</a:t>
+            </a:r>
+            <a:endParaRPr lang="en-US" sz="1100" dirty="0"/>
+          </a:p>
+          <a:p>
+            <a:pPr marL="342900" indent="-342900">
+              <a:spcAft>
+                <a:spcPts val="400"/>
+              </a:spcAft>
+              <a:buSzPct val="100000"/>
+              <a:buChar char="•"/>
+            </a:pPr>
+            <a:r>
+              <a:rPr lang="en-US" sz="1100" dirty="0">
+                <a:solidFill>
+                  <a:srgbClr val="1B1A19"/>
+                </a:solidFill>
+                <a:latin typeface="Calibri" pitchFamily="34" charset="0"/>
+                <a:ea typeface="Calibri" pitchFamily="34" charset="-122"/>
+                <a:cs typeface="Calibri" pitchFamily="34" charset="-120"/>
+              </a:rPr>
+              <a:t>Los costos del sesgo se trasladan al presupuesto del observatorio, no a los países.</a:t>
+            </a:r>
+            <a:endParaRPr lang="en-US" sz="1100" dirty="0"/>
+          </a:p>
+        </p:txBody>
+      </p:sp>
+      <p:sp>
+        <p:nvSpPr>
+          <p:cNvPr id="13" name="Shape 9"/>
+          <p:cNvSpPr/>
+          <p:nvPr/>
+        </p:nvSpPr>
+        <p:spPr>
+          <a:xfrm>
+            <a:off x="7726680" y="1417320"/>
+            <a:ext cx="3916375" cy="2148840"/>
+          </a:xfrm>
+          <a:prstGeom prst="roundRect">
+            <a:avLst>
+              <a:gd name="adj" fmla="val 3404"/>
+            </a:avLst>
+          </a:prstGeom>
+          <a:solidFill>
+            <a:srgbClr val="F4F2EF"/>
+          </a:solidFill>
+          <a:ln w="12700">
+            <a:solidFill>
+              <a:srgbClr val="F4F2EF"/>
+            </a:solidFill>
+            <a:prstDash val="solid"/>
+          </a:ln>
+        </p:spPr>
+      </p:sp>
+      <p:sp>
+        <p:nvSpPr>
+          <p:cNvPr id="14" name="Text 10"/>
+          <p:cNvSpPr txBox="1"/>
+          <p:nvPr/>
+        </p:nvSpPr>
+        <p:spPr>
+          <a:xfrm>
+            <a:off x="7909560" y="1554480"/>
+            <a:ext cx="3550615" cy="365760"/>
+          </a:xfrm>
+          <a:prstGeom prst="rect">
+            <a:avLst/>
+          </a:prstGeom>
+          <a:noFill/>
+          <a:ln/>
+        </p:spPr>
+        <p:txBody>
+          <a:bodyPr wrap="square" lIns="0" tIns="0" rIns="0" bIns="0" rtlCol="0" anchor="t"/>
+          <a:lstStyle/>
+          <a:p>
+            <a:pPr indent="0" marL="0">
+              <a:buNone/>
+            </a:pPr>
+            <a:r>
+              <a:rPr lang="en-US" sz="1400" b="1" dirty="0">
+                <a:solidFill>
+                  <a:srgbClr val="7A1F3D"/>
+                </a:solidFill>
+                <a:latin typeface="Calibri" pitchFamily="34" charset="0"/>
+                <a:ea typeface="Calibri" pitchFamily="34" charset="-122"/>
+                <a:cs typeface="Calibri" pitchFamily="34" charset="-120"/>
+              </a:rPr>
+              <a:t>Stakeholders y riesgos</a:t>
+            </a:r>
+            <a:endParaRPr lang="en-US" sz="1400" dirty="0"/>
+          </a:p>
+        </p:txBody>
+      </p:sp>
+      <p:sp>
+        <p:nvSpPr>
+          <p:cNvPr id="15" name="Text 11"/>
+          <p:cNvSpPr txBox="1"/>
+          <p:nvPr/>
+        </p:nvSpPr>
+        <p:spPr>
+          <a:xfrm>
+            <a:off x="7909560" y="1920240"/>
+            <a:ext cx="3550615" cy="1508760"/>
+          </a:xfrm>
+          <a:prstGeom prst="rect">
+            <a:avLst/>
+          </a:prstGeom>
+          <a:noFill/>
+          <a:ln/>
+        </p:spPr>
+        <p:txBody>
+          <a:bodyPr wrap="square" lIns="0" tIns="0" rIns="0" bIns="0" rtlCol="0" anchor="t"/>
+          <a:lstStyle/>
+          <a:p>
+            <a:pPr marL="342900" indent="-342900">
+              <a:spcAft>
+                <a:spcPts val="400"/>
+              </a:spcAft>
+              <a:buSzPct val="100000"/>
+              <a:buChar char="•"/>
+            </a:pPr>
+            <a:r>
+              <a:rPr lang="en-US" sz="1100" dirty="0">
+                <a:solidFill>
+                  <a:srgbClr val="1B1A19"/>
+                </a:solidFill>
+                <a:latin typeface="Calibri" pitchFamily="34" charset="0"/>
+                <a:ea typeface="Calibri" pitchFamily="34" charset="-122"/>
+                <a:cs typeface="Calibri" pitchFamily="34" charset="-120"/>
+              </a:rPr>
+              <a:t>Codificadores (sesgo de automatización) · coordinación GENIAL (índice con error) · países comparados (uso reputacional del ranking) · jurisdicciones pequeñas y no hispanohablantes (invisibilización) · comunidad (reutilización).</a:t>
+            </a:r>
+            <a:endParaRPr lang="en-US" sz="1100" dirty="0"/>
+          </a:p>
+          <a:p>
+            <a:pPr marL="342900" indent="-342900">
+              <a:spcAft>
+                <a:spcPts val="400"/>
+              </a:spcAft>
+              <a:buSzPct val="100000"/>
+              <a:buChar char="•"/>
+            </a:pPr>
+            <a:r>
+              <a:rPr lang="en-US" sz="1100" dirty="0">
+                <a:solidFill>
+                  <a:srgbClr val="1B1A19"/>
+                </a:solidFill>
+                <a:latin typeface="Calibri" pitchFamily="34" charset="0"/>
+                <a:ea typeface="Calibri" pitchFamily="34" charset="-122"/>
+                <a:cs typeface="Calibri" pitchFamily="34" charset="-120"/>
+              </a:rPr>
+              <a:t>Privacidad: el nombre del codificador es dato personal; se excluye del modelo y se anonimiza. Ley de IA de la UE: riesgo mínimo (no decide sobre personas).</a:t>
+            </a:r>
+            <a:endParaRPr lang="en-US" sz="1100" dirty="0"/>
+          </a:p>
+        </p:txBody>
+      </p:sp>
+      <p:sp>
+        <p:nvSpPr>
+          <p:cNvPr id="16" name="Shape 12"/>
+          <p:cNvSpPr/>
+          <p:nvPr/>
+        </p:nvSpPr>
+        <p:spPr>
+          <a:xfrm>
+            <a:off x="7726680" y="3703320"/>
+            <a:ext cx="3916375" cy="2240280"/>
+          </a:xfrm>
+          <a:prstGeom prst="roundRect">
+            <a:avLst>
+              <a:gd name="adj" fmla="val 3265"/>
+            </a:avLst>
+          </a:prstGeom>
+          <a:solidFill>
+            <a:srgbClr val="F3E6EA"/>
+          </a:solidFill>
+          <a:ln w="12700">
+            <a:solidFill>
+              <a:srgbClr val="F3E6EA"/>
+            </a:solidFill>
+            <a:prstDash val="solid"/>
+          </a:ln>
+        </p:spPr>
+      </p:sp>
+      <p:sp>
+        <p:nvSpPr>
+          <p:cNvPr id="17" name="Text 13"/>
+          <p:cNvSpPr txBox="1"/>
+          <p:nvPr/>
+        </p:nvSpPr>
+        <p:spPr>
+          <a:xfrm>
+            <a:off x="7909560" y="3840480"/>
+            <a:ext cx="3550615" cy="365760"/>
+          </a:xfrm>
+          <a:prstGeom prst="rect">
+            <a:avLst/>
+          </a:prstGeom>
+          <a:noFill/>
+          <a:ln/>
+        </p:spPr>
+        <p:txBody>
+          <a:bodyPr wrap="square" lIns="0" tIns="0" rIns="0" bIns="0" rtlCol="0" anchor="t"/>
+          <a:lstStyle/>
+          <a:p>
+            <a:pPr indent="0" marL="0">
+              <a:buNone/>
+            </a:pPr>
+            <a:r>
+              <a:rPr lang="en-US" sz="1400" b="1" dirty="0">
+                <a:solidFill>
+                  <a:srgbClr val="7A1F3D"/>
+                </a:solidFill>
+                <a:latin typeface="Calibri" pitchFamily="34" charset="0"/>
+                <a:ea typeface="Calibri" pitchFamily="34" charset="-122"/>
+                <a:cs typeface="Calibri" pitchFamily="34" charset="-120"/>
+              </a:rPr>
+              <a:t>Compromisos</a:t>
+            </a:r>
+            <a:endParaRPr lang="en-US" sz="1400" dirty="0"/>
+          </a:p>
+        </p:txBody>
+      </p:sp>
+      <p:sp>
+        <p:nvSpPr>
+          <p:cNvPr id="18" name="Text 14"/>
+          <p:cNvSpPr txBox="1"/>
+          <p:nvPr/>
+        </p:nvSpPr>
+        <p:spPr>
+          <a:xfrm>
+            <a:off x="7909560" y="4206240"/>
+            <a:ext cx="3550615" cy="1600200"/>
+          </a:xfrm>
+          <a:prstGeom prst="rect">
+            <a:avLst/>
+          </a:prstGeom>
+          <a:noFill/>
+          <a:ln/>
+        </p:spPr>
+        <p:txBody>
+          <a:bodyPr wrap="square" lIns="0" tIns="0" rIns="0" bIns="0" rtlCol="0" anchor="t"/>
+          <a:lstStyle/>
+          <a:p>
+            <a:pPr marL="342900" indent="-342900">
+              <a:spcAft>
+                <a:spcPts val="400"/>
+              </a:spcAft>
+              <a:buSzPct val="100000"/>
+              <a:buChar char="•"/>
+            </a:pPr>
+            <a:r>
+              <a:rPr lang="en-US" sz="1100" dirty="0">
+                <a:solidFill>
+                  <a:srgbClr val="1B1A19"/>
+                </a:solidFill>
+                <a:latin typeface="Calibri" pitchFamily="34" charset="0"/>
+                <a:ea typeface="Calibri" pitchFamily="34" charset="-122"/>
+                <a:cs typeface="Calibri" pitchFamily="34" charset="-120"/>
+              </a:rPr>
+              <a:t>Auditoría de equidad en cada versión; ningún valor del IMN sin revisión humana en los grupos en riesgo.</a:t>
+            </a:r>
+            <a:endParaRPr lang="en-US" sz="1100" dirty="0"/>
+          </a:p>
+          <a:p>
+            <a:pPr marL="342900" indent="-342900">
+              <a:spcAft>
+                <a:spcPts val="400"/>
+              </a:spcAft>
+              <a:buSzPct val="100000"/>
+              <a:buChar char="•"/>
+            </a:pPr>
+            <a:r>
+              <a:rPr lang="en-US" sz="1100" dirty="0">
+                <a:solidFill>
+                  <a:srgbClr val="1B1A19"/>
+                </a:solidFill>
+                <a:latin typeface="Calibri" pitchFamily="34" charset="0"/>
+                <a:ea typeface="Calibri" pitchFamily="34" charset="-122"/>
+                <a:cs typeface="Calibri" pitchFamily="34" charset="-120"/>
+              </a:rPr>
+              <a:t>Cada cifra del IMN con su margen y su porcentaje de respaldo humano; model card y datasheet actualizadas.</a:t>
+            </a:r>
+            <a:endParaRPr lang="en-US" sz="1100" dirty="0"/>
+          </a:p>
+          <a:p>
+            <a:pPr marL="342900" indent="-342900">
+              <a:spcAft>
+                <a:spcPts val="400"/>
+              </a:spcAft>
+              <a:buSzPct val="100000"/>
+              <a:buChar char="•"/>
+            </a:pPr>
+            <a:r>
+              <a:rPr lang="en-US" sz="1100" dirty="0">
+                <a:solidFill>
+                  <a:srgbClr val="1B1A19"/>
+                </a:solidFill>
+                <a:latin typeface="Calibri" pitchFamily="34" charset="0"/>
+                <a:ea typeface="Calibri" pitchFamily="34" charset="-122"/>
+                <a:cs typeface="Calibri" pitchFamily="34" charset="-120"/>
+              </a:rPr>
+              <a:t>El modelo nunca evalúa a codificadores individuales; canal de apelación para países e IES.</a:t>
+            </a:r>
+            <a:endParaRPr lang="en-US" sz="1100" dirty="0"/>
+          </a:p>
+        </p:txBody>
+      </p:sp>
+    </p:spTree>
+  </p:cSld>
+  <p:clrMapOvr>
+    <a:masterClrMapping/>
+  </p:clrMapOvr>
+</p:sld>
+</file>
+
+<file path=ppt/slides/slide17.xml><?xml version="1.0" encoding="utf-8"?>
+<p:sld xmlns:a="http://schemas.openxmlformats.org/drawingml/2006/main" xmlns:r="http://schemas.openxmlformats.org/officeDocument/2006/relationships" xmlns:p="http://schemas.openxmlformats.org/presentationml/2006/main">
+  <p:cSld name="Slide 17">
+    <p:bg>
+      <p:bgPr>
+        <a:solidFill>
+          <a:srgbClr val="FFFFFF"/>
+        </a:solidFill>
+      </p:bgPr>
+    </p:bg>
+    <p:spTree>
+      <p:nvGrpSpPr>
+        <p:cNvPr id="1" name=""/>
+        <p:cNvGrpSpPr/>
+        <p:nvPr/>
+      </p:nvGrpSpPr>
+      <p:grpSpPr>
+        <a:xfrm>
+          <a:off x="0" y="0"/>
+          <a:ext cx="0" cy="0"/>
+          <a:chOff x="0" y="0"/>
+          <a:chExt cx="0" cy="0"/>
+        </a:xfrm>
+      </p:grpSpPr>
+      <p:sp>
+        <p:nvSpPr>
+          <p:cNvPr id="2" name="Shape 0"/>
+          <p:cNvSpPr/>
+          <p:nvPr/>
+        </p:nvSpPr>
+        <p:spPr>
+          <a:xfrm>
+            <a:off x="548640" y="457200"/>
+            <a:ext cx="457200" cy="457200"/>
+          </a:xfrm>
+          <a:prstGeom prst="ellipse">
+            <a:avLst/>
+          </a:prstGeom>
+          <a:solidFill>
+            <a:srgbClr val="7A1F3D"/>
+          </a:solidFill>
+          <a:ln w="12700">
+            <a:solidFill>
+              <a:srgbClr val="7A1F3D"/>
+            </a:solidFill>
+            <a:prstDash val="solid"/>
+          </a:ln>
+        </p:spPr>
+      </p:sp>
+      <p:sp>
+        <p:nvSpPr>
+          <p:cNvPr id="3" name="Text 1"/>
+          <p:cNvSpPr txBox="1"/>
+          <p:nvPr/>
+        </p:nvSpPr>
+        <p:spPr>
+          <a:xfrm>
+            <a:off x="548640" y="457200"/>
+            <a:ext cx="457200" cy="457200"/>
+          </a:xfrm>
+          <a:prstGeom prst="rect">
+            <a:avLst/>
+          </a:prstGeom>
+          <a:noFill/>
+          <a:ln/>
+        </p:spPr>
+        <p:txBody>
+          <a:bodyPr wrap="square" lIns="0" tIns="0" rIns="0" bIns="0" rtlCol="0" anchor="ctr"/>
+          <a:lstStyle/>
+          <a:p>
+            <a:pPr algn="ctr" indent="0" marL="0">
+              <a:buNone/>
+            </a:pPr>
+            <a:r>
+              <a:rPr lang="en-US" sz="1400" b="1" dirty="0">
+                <a:solidFill>
+                  <a:srgbClr val="FFFFFF"/>
+                </a:solidFill>
+                <a:latin typeface="Calibri" pitchFamily="34" charset="0"/>
+                <a:ea typeface="Calibri" pitchFamily="34" charset="-122"/>
+                <a:cs typeface="Calibri" pitchFamily="34" charset="-120"/>
+              </a:rPr>
+              <a:t>15</a:t>
+            </a:r>
+            <a:endParaRPr lang="en-US" sz="1400" dirty="0"/>
+          </a:p>
+        </p:txBody>
+      </p:sp>
+      <p:sp>
+        <p:nvSpPr>
+          <p:cNvPr id="4" name="Text 2"/>
+          <p:cNvSpPr txBox="1"/>
+          <p:nvPr/>
+        </p:nvSpPr>
+        <p:spPr>
+          <a:xfrm>
+            <a:off x="1188720" y="365760"/>
+            <a:ext cx="10454335" cy="640080"/>
+          </a:xfrm>
+          <a:prstGeom prst="rect">
+            <a:avLst/>
+          </a:prstGeom>
+          <a:noFill/>
+          <a:ln/>
+        </p:spPr>
+        <p:txBody>
+          <a:bodyPr wrap="square" lIns="0" tIns="0" rIns="0" bIns="0" rtlCol="0" anchor="ctr"/>
+          <a:lstStyle/>
+          <a:p>
+            <a:pPr indent="0" marL="0">
+              <a:buNone/>
+            </a:pPr>
+            <a:r>
+              <a:rPr lang="en-US" sz="2800" b="1" dirty="0">
+                <a:solidFill>
+                  <a:srgbClr val="1B1A19"/>
+                </a:solidFill>
+                <a:latin typeface="Cambria" pitchFamily="34" charset="0"/>
+                <a:ea typeface="Cambria" pitchFamily="34" charset="-122"/>
+                <a:cs typeface="Cambria" pitchFamily="34" charset="-120"/>
+              </a:rPr>
               <a:t>Contraste con los umbrales prefijados y limitaciones</a:t>
             </a:r>
             <a:endParaRPr lang="en-US" sz="2800" dirty="0"/>
@@ -14734,7 +15532,7 @@
                 <a:ea typeface="Calibri" pitchFamily="34" charset="-122"/>
                 <a:cs typeface="Calibri" pitchFamily="34" charset="-120"/>
               </a:rPr>
-              <a:t>16</a:t>
+              <a:t>17</a:t>
             </a:r>
             <a:endParaRPr lang="en-US" sz="900" dirty="0"/>
           </a:p>
@@ -14742,7 +15540,7 @@
       </p:sp>
       <p:graphicFrame>
         <p:nvGraphicFramePr>
-          <p:cNvPr id="17" name="Table 0"/>
+          <p:cNvPr id="18" name="Table 0"/>
           <p:cNvGraphicFramePr>
             <a:graphicFrameLocks noGrp="1"/>
           </p:cNvGraphicFramePr>
@@ -16360,9 +17158,9 @@
 </p:sld>
 </file>
 
-<file path=ppt/slides/slide17.xml><?xml version="1.0" encoding="utf-8"?>
+<file path=ppt/slides/slide18.xml><?xml version="1.0" encoding="utf-8"?>
 <p:sld xmlns:a="http://schemas.openxmlformats.org/drawingml/2006/main" xmlns:r="http://schemas.openxmlformats.org/officeDocument/2006/relationships" xmlns:p="http://schemas.openxmlformats.org/presentationml/2006/main">
-  <p:cSld name="Slide 17">
+  <p:cSld name="Slide 18">
     <p:bg>
       <p:bgPr>
         <a:solidFill>
@@ -16442,7 +17240,7 @@
                 <a:ea typeface="Calibri" pitchFamily="34" charset="-122"/>
                 <a:cs typeface="Calibri" pitchFamily="34" charset="-120"/>
               </a:rPr>
-              <a:t>15</a:t>
+              <a:t>16</a:t>
             </a:r>
             <a:endParaRPr lang="en-US" sz="1400" dirty="0"/>
           </a:p>
@@ -16559,7 +17357,7 @@
                 <a:ea typeface="Calibri" pitchFamily="34" charset="-122"/>
                 <a:cs typeface="Calibri" pitchFamily="34" charset="-120"/>
               </a:rPr>
-              <a:t>17</a:t>
+              <a:t>18</a:t>
             </a:r>
             <a:endParaRPr lang="en-US" sz="900" dirty="0"/>
           </a:p>
@@ -17431,9 +18229,9 @@
 </p:sld>
 </file>
 
-<file path=ppt/slides/slide18.xml><?xml version="1.0" encoding="utf-8"?>
+<file path=ppt/slides/slide19.xml><?xml version="1.0" encoding="utf-8"?>
 <p:sld xmlns:a="http://schemas.openxmlformats.org/drawingml/2006/main" xmlns:r="http://schemas.openxmlformats.org/officeDocument/2006/relationships" xmlns:p="http://schemas.openxmlformats.org/presentationml/2006/main">
-  <p:cSld name="Slide 18">
+  <p:cSld name="Slide 19">
     <p:bg>
       <p:bgPr>
         <a:solidFill>
@@ -18957,7 +19755,7 @@
                 <a:ea typeface="Calibri" pitchFamily="34" charset="-122"/>
                 <a:cs typeface="Calibri" pitchFamily="34" charset="-120"/>
               </a:rPr>
-              <a:t>Umbrales, limitaciones y conclusiones</a:t>
+              <a:t>Impacto social, umbrales y conclusiones</a:t>
             </a:r>
             <a:endParaRPr lang="en-US" sz="1600" dirty="0"/>
           </a:p>
@@ -18974,7 +19772,7 @@
                 <a:ea typeface="Calibri" pitchFamily="34" charset="-122"/>
                 <a:cs typeface="Calibri" pitchFamily="34" charset="-120"/>
               </a:rPr>
-              <a:t>lo que se cumplió y lo que no</a:t>
+              <a:t>equidad por jurisdicción, lo que se cumplió y lo que no</a:t>
             </a:r>
             <a:endParaRPr lang="en-US" sz="1600" dirty="0"/>
           </a:p>
@@ -19013,7 +19811,7 @@
                 <a:ea typeface="Calibri" pitchFamily="34" charset="-122"/>
                 <a:cs typeface="Calibri" pitchFamily="34" charset="-120"/>
               </a:rPr>
-              <a:t>min 13:25</a:t>
+              <a:t>min 13:10</a:t>
             </a:r>
             <a:endParaRPr lang="en-US" sz="1100" dirty="0"/>
           </a:p>

</xml_diff>